<commit_message>
docs(pptx): actualizar portada y agregar slides de app y formato del profesor
Portada (slide 1):
- Equipo completo con códigos UAO: Joan Mateo Cardona 2243431,
  Danna Villegas 2240027, Jorge Eduardo Álvarez 2230610.
- Línea inferior con "Grupo 1" y "Sustentación: semana 16".

Nuevas slides:
- Slide 18 (Aplicativo web entregado): describe los cinco paneles del
  dashboard, la suite de 11 tests, la CI y la URL pública en Vercel.
- Slide 19 (Soporte al formato del profesor): documenta el formato
  extendido 'Cat1,…,CatN--records', los tres casos de data_2026_1/
  con sus tamaños y tiempos medidos, y referencia el test 11.

Slides 2-17 sin cambios: el contenido técnico (QuickSort, búsqueda
binaria, recursividad, tablas de complejidad, trazabilidad de
Prácticas 4/5/6) sigue siendo exacto frente al código actual.

Incluye docs/_update_pptx.py para regenerar la actualización si
hace falta repetirla.
</commit_message>
<xml_diff>
--- a/docs/TareaFinal_EDyA1_Presentacion.pptx
+++ b/docs/TareaFinal_EDyA1_Presentacion.pptx
@@ -22,6 +22,8 @@
     <p:sldId id="270" r:id="rId16"/>
     <p:sldId id="271" r:id="rId17"/>
     <p:sldId id="272" r:id="rId18"/>
+    <p:sldId id="273" r:id="rId24"/>
+    <p:sldId id="274" r:id="rId25"/>
   </p:sldIdLst>
   <p:notesMasterIdLst>
     <p:notesMasterId r:id="rId19"/>
@@ -2718,15 +2720,13 @@
               <a:buNone/>
             </a:pPr>
             <a:r>
-              <a:rPr lang="en-US" sz="1400" b="1" dirty="0">
+              <a:rPr sz="1400" b="1">
                 <a:solidFill>
                   <a:srgbClr val="FFFFFF"/>
                 </a:solidFill>
-                <a:latin typeface="Calibri" pitchFamily="34" charset="0"/>
-                <a:ea typeface="Calibri" pitchFamily="34" charset="-122"/>
-                <a:cs typeface="Calibri" pitchFamily="34" charset="-120"/>
-              </a:rPr>
-              <a:t>Joan Mateo Cardona</a:t>
+                <a:latin typeface="Calibri"/>
+              </a:rPr>
+              <a:t>Joan Mateo Cardona 2243431  •  Danna Villegas 2240027  •  Jorge Eduardo Álvarez 2230610</a:t>
             </a:r>
             <a:endParaRPr lang="en-US" sz="1400" dirty="0"/>
           </a:p>
@@ -2757,15 +2757,13 @@
               <a:buNone/>
             </a:pPr>
             <a:r>
-              <a:rPr lang="en-US" sz="1100" i="1" dirty="0">
+              <a:rPr sz="1100">
                 <a:solidFill>
                   <a:srgbClr val="CBD5E1"/>
                 </a:solidFill>
-                <a:latin typeface="Calibri" pitchFamily="34" charset="0"/>
-                <a:ea typeface="Calibri" pitchFamily="34" charset="-122"/>
-                <a:cs typeface="Calibri" pitchFamily="34" charset="-120"/>
-              </a:rPr>
-              <a:t>Entrega: 17 de mayo de 2026</a:t>
+                <a:latin typeface="Calibri"/>
+              </a:rPr>
+              <a:t>Grupo 1  •  Entrega: 17 de mayo de 2026  •  Sustentación: semana 16</a:t>
             </a:r>
             <a:endParaRPr lang="en-US" sz="1100" dirty="0"/>
           </a:p>
@@ -8548,6 +8546,500 @@
               <a:t>¿Preguntas?</a:t>
             </a:r>
             <a:endParaRPr lang="en-US" sz="1400" dirty="0"/>
+          </a:p>
+        </p:txBody>
+      </p:sp>
+    </p:spTree>
+  </p:cSld>
+  <p:clrMapOvr>
+    <a:masterClrMapping/>
+  </p:clrMapOvr>
+</p:sld>
+</file>
+
+<file path=ppt/slides/slide18.xml><?xml version="1.0" encoding="utf-8"?>
+<p:sld xmlns:a="http://schemas.openxmlformats.org/drawingml/2006/main" xmlns:p="http://schemas.openxmlformats.org/presentationml/2006/main" xmlns:r="http://schemas.openxmlformats.org/officeDocument/2006/relationships">
+  <p:cSld>
+    <p:spTree>
+      <p:nvGrpSpPr>
+        <p:cNvPr id="1" name=""/>
+        <p:cNvGrpSpPr/>
+        <p:nvPr/>
+      </p:nvGrpSpPr>
+      <p:grpSpPr/>
+      <p:sp>
+        <p:nvSpPr>
+          <p:cNvPr id="2" name="TextBox 1"/>
+          <p:cNvSpPr txBox="1"/>
+          <p:nvPr/>
+        </p:nvSpPr>
+        <p:spPr>
+          <a:xfrm>
+            <a:off x="731520" y="548640"/>
+            <a:ext cx="10515600" cy="731520"/>
+          </a:xfrm>
+          <a:prstGeom prst="rect">
+            <a:avLst/>
+          </a:prstGeom>
+          <a:noFill/>
+        </p:spPr>
+        <p:txBody>
+          <a:bodyPr wrap="square">
+            <a:spAutoFit/>
+          </a:bodyPr>
+          <a:lstStyle/>
+          <a:p>
+            <a:r>
+              <a:rPr sz="3600" b="1">
+                <a:solidFill>
+                  <a:srgbClr val="0F172A"/>
+                </a:solidFill>
+                <a:latin typeface="Calibri"/>
+              </a:rPr>
+              <a:t>Aplicativo web entregado</a:t>
+            </a:r>
+          </a:p>
+        </p:txBody>
+      </p:sp>
+      <p:sp>
+        <p:nvSpPr>
+          <p:cNvPr id="3" name="TextBox 2"/>
+          <p:cNvSpPr txBox="1"/>
+          <p:nvPr/>
+        </p:nvSpPr>
+        <p:spPr>
+          <a:xfrm>
+            <a:off x="731520" y="1280160"/>
+            <a:ext cx="10515600" cy="365760"/>
+          </a:xfrm>
+          <a:prstGeom prst="rect">
+            <a:avLst/>
+          </a:prstGeom>
+          <a:noFill/>
+        </p:spPr>
+        <p:txBody>
+          <a:bodyPr wrap="none">
+            <a:spAutoFit/>
+          </a:bodyPr>
+          <a:lstStyle/>
+          <a:p>
+            <a:r>
+              <a:rPr sz="1800">
+                <a:solidFill>
+                  <a:srgbClr val="475569"/>
+                </a:solidFill>
+                <a:latin typeface="Calibri"/>
+              </a:rPr>
+              <a:t>PWA con cinco paneles + integración continua</a:t>
+            </a:r>
+          </a:p>
+        </p:txBody>
+      </p:sp>
+      <p:sp>
+        <p:nvSpPr>
+          <p:cNvPr id="4" name="TextBox 3"/>
+          <p:cNvSpPr txBox="1"/>
+          <p:nvPr/>
+        </p:nvSpPr>
+        <p:spPr>
+          <a:xfrm>
+            <a:off x="731520" y="1920240"/>
+            <a:ext cx="10515600" cy="4572000"/>
+          </a:xfrm>
+          <a:prstGeom prst="rect">
+            <a:avLst/>
+          </a:prstGeom>
+          <a:noFill/>
+        </p:spPr>
+        <p:txBody>
+          <a:bodyPr wrap="square">
+            <a:spAutoFit/>
+          </a:bodyPr>
+          <a:lstStyle/>
+          <a:p>
+            <a:pPr>
+              <a:spcAft>
+                <a:spcPts val="800"/>
+              </a:spcAft>
+            </a:pPr>
+            <a:r>
+              <a:rPr sz="1800">
+                <a:solidFill>
+                  <a:srgbClr val="0F172A"/>
+                </a:solidFill>
+                <a:latin typeface="Calibri"/>
+              </a:rPr>
+              <a:t>• Resultados: ranking, métricas y gráficos del ejecutado.</a:t>
+            </a:r>
+          </a:p>
+          <a:p>
+            <a:pPr>
+              <a:spcAft>
+                <a:spcPts val="800"/>
+              </a:spcAft>
+            </a:pPr>
+            <a:r>
+              <a:rPr sz="1800">
+                <a:solidFill>
+                  <a:srgbClr val="0F172A"/>
+                </a:solidFill>
+                <a:latin typeface="Calibri"/>
+              </a:rPr>
+              <a:t>• Cargar caso: pegado, CSV, generador sintético (m, n, p, seed) y casos del profesor.</a:t>
+            </a:r>
+          </a:p>
+          <a:p>
+            <a:pPr>
+              <a:spcAft>
+                <a:spcPts val="800"/>
+              </a:spcAft>
+            </a:pPr>
+            <a:r>
+              <a:rPr sz="1800">
+                <a:solidFill>
+                  <a:srgbClr val="0F172A"/>
+                </a:solidFill>
+                <a:latin typeface="Calibri"/>
+              </a:rPr>
+              <a:t>• Benchmark: MergeSort, QuickSort 3-way, RadixSort, Insertion y Array.sort sobre el mismo dataset.</a:t>
+            </a:r>
+          </a:p>
+          <a:p>
+            <a:pPr>
+              <a:spcAft>
+                <a:spcPts val="800"/>
+              </a:spcAft>
+            </a:pPr>
+            <a:r>
+              <a:rPr sz="1800">
+                <a:solidFill>
+                  <a:srgbClr val="0F172A"/>
+                </a:solidFill>
+                <a:latin typeface="Calibri"/>
+              </a:rPr>
+              <a:t>• Pruebas: suite automatizada de 11 tests (Node + navegador).</a:t>
+            </a:r>
+          </a:p>
+          <a:p>
+            <a:pPr>
+              <a:spcAft>
+                <a:spcPts val="800"/>
+              </a:spcAft>
+            </a:pPr>
+            <a:r>
+              <a:rPr sz="1800">
+                <a:solidFill>
+                  <a:srgbClr val="0F172A"/>
+                </a:solidFill>
+                <a:latin typeface="Calibri"/>
+              </a:rPr>
+              <a:t>• Documentación: complejidad, decisiones de diseño y trazabilidad de prácticas.</a:t>
+            </a:r>
+          </a:p>
+          <a:p>
+            <a:pPr>
+              <a:spcAft>
+                <a:spcPts val="800"/>
+              </a:spcAft>
+            </a:pPr>
+            <a:r>
+              <a:rPr sz="1800">
+                <a:solidFill>
+                  <a:srgbClr val="0F172A"/>
+                </a:solidFill>
+                <a:latin typeface="Calibri"/>
+              </a:rPr>
+              <a:t>• CI con GitHub Actions ejecuta los tests antes de cada despliegue.</a:t>
+            </a:r>
+          </a:p>
+        </p:txBody>
+      </p:sp>
+      <p:sp>
+        <p:nvSpPr>
+          <p:cNvPr id="5" name="TextBox 4"/>
+          <p:cNvSpPr txBox="1"/>
+          <p:nvPr/>
+        </p:nvSpPr>
+        <p:spPr>
+          <a:xfrm>
+            <a:off x="731520" y="6126480"/>
+            <a:ext cx="10515600" cy="365760"/>
+          </a:xfrm>
+          <a:prstGeom prst="rect">
+            <a:avLst/>
+          </a:prstGeom>
+          <a:noFill/>
+        </p:spPr>
+        <p:txBody>
+          <a:bodyPr wrap="none">
+            <a:spAutoFit/>
+          </a:bodyPr>
+          <a:lstStyle/>
+          <a:p>
+            <a:r>
+              <a:rPr sz="1600">
+                <a:solidFill>
+                  <a:srgbClr val="2563EB"/>
+                </a:solidFill>
+                <a:latin typeface="Calibri"/>
+              </a:rPr>
+              <a:t>Demo en vivo: https://tarea-final-e-dy-a1.vercel.app/app/index.html</a:t>
+            </a:r>
+          </a:p>
+        </p:txBody>
+      </p:sp>
+    </p:spTree>
+  </p:cSld>
+  <p:clrMapOvr>
+    <a:masterClrMapping/>
+  </p:clrMapOvr>
+</p:sld>
+</file>
+
+<file path=ppt/slides/slide19.xml><?xml version="1.0" encoding="utf-8"?>
+<p:sld xmlns:a="http://schemas.openxmlformats.org/drawingml/2006/main" xmlns:p="http://schemas.openxmlformats.org/presentationml/2006/main" xmlns:r="http://schemas.openxmlformats.org/officeDocument/2006/relationships">
+  <p:cSld>
+    <p:spTree>
+      <p:nvGrpSpPr>
+        <p:cNvPr id="1" name=""/>
+        <p:cNvGrpSpPr/>
+        <p:nvPr/>
+      </p:nvGrpSpPr>
+      <p:grpSpPr/>
+      <p:sp>
+        <p:nvSpPr>
+          <p:cNvPr id="2" name="TextBox 1"/>
+          <p:cNvSpPr txBox="1"/>
+          <p:nvPr/>
+        </p:nvSpPr>
+        <p:spPr>
+          <a:xfrm>
+            <a:off x="731520" y="548640"/>
+            <a:ext cx="10515600" cy="731520"/>
+          </a:xfrm>
+          <a:prstGeom prst="rect">
+            <a:avLst/>
+          </a:prstGeom>
+          <a:noFill/>
+        </p:spPr>
+        <p:txBody>
+          <a:bodyPr wrap="square">
+            <a:spAutoFit/>
+          </a:bodyPr>
+          <a:lstStyle/>
+          <a:p>
+            <a:r>
+              <a:rPr sz="3600" b="1">
+                <a:solidFill>
+                  <a:srgbClr val="0F172A"/>
+                </a:solidFill>
+                <a:latin typeface="Calibri"/>
+              </a:rPr>
+              <a:t>Soporte al formato del profesor</a:t>
+            </a:r>
+          </a:p>
+        </p:txBody>
+      </p:sp>
+      <p:sp>
+        <p:nvSpPr>
+          <p:cNvPr id="3" name="TextBox 2"/>
+          <p:cNvSpPr txBox="1"/>
+          <p:nvPr/>
+        </p:nvSpPr>
+        <p:spPr>
+          <a:xfrm>
+            <a:off x="731520" y="1280160"/>
+            <a:ext cx="10515600" cy="365760"/>
+          </a:xfrm>
+          <a:prstGeom prst="rect">
+            <a:avLst/>
+          </a:prstGeom>
+          <a:noFill/>
+        </p:spPr>
+        <p:txBody>
+          <a:bodyPr wrap="none">
+            <a:spAutoFit/>
+          </a:bodyPr>
+          <a:lstStyle/>
+          <a:p>
+            <a:r>
+              <a:rPr sz="1800">
+                <a:solidFill>
+                  <a:srgbClr val="475569"/>
+                </a:solidFill>
+                <a:latin typeface="Calibri"/>
+              </a:rPr>
+              <a:t>Casos publicados en data_2026_1/</a:t>
+            </a:r>
+          </a:p>
+        </p:txBody>
+      </p:sp>
+      <p:sp>
+        <p:nvSpPr>
+          <p:cNvPr id="4" name="TextBox 3"/>
+          <p:cNvSpPr txBox="1"/>
+          <p:nvPr/>
+        </p:nvSpPr>
+        <p:spPr>
+          <a:xfrm>
+            <a:off x="731520" y="1920240"/>
+            <a:ext cx="10515600" cy="4572000"/>
+          </a:xfrm>
+          <a:prstGeom prst="rect">
+            <a:avLst/>
+          </a:prstGeom>
+          <a:noFill/>
+        </p:spPr>
+        <p:txBody>
+          <a:bodyPr wrap="square">
+            <a:spAutoFit/>
+          </a:bodyPr>
+          <a:lstStyle/>
+          <a:p>
+            <a:pPr>
+              <a:spcAft>
+                <a:spcPts val="800"/>
+              </a:spcAft>
+            </a:pPr>
+            <a:r>
+              <a:rPr sz="1800">
+                <a:solidFill>
+                  <a:srgbClr val="0F172A"/>
+                </a:solidFill>
+                <a:latin typeface="Calibri"/>
+              </a:rPr>
+              <a:t>• Formato extendido: 'Cat1,Cat2,…,CatN--customer product category price quantity timestamp;…'</a:t>
+            </a:r>
+          </a:p>
+          <a:p>
+            <a:pPr>
+              <a:spcAft>
+                <a:spcPts val="800"/>
+              </a:spcAft>
+            </a:pPr>
+            <a:r>
+              <a:rPr sz="1800">
+                <a:solidFill>
+                  <a:srgbClr val="0F172A"/>
+                </a:solidFill>
+                <a:latin typeface="Calibri"/>
+              </a:rPr>
+              <a:t>• El parser detecta automáticamente comillas externas, separador '--' y lista de categorías.</a:t>
+            </a:r>
+          </a:p>
+          <a:p>
+            <a:pPr>
+              <a:spcAft>
+                <a:spcPts val="800"/>
+              </a:spcAft>
+            </a:pPr>
+            <a:r>
+              <a:rPr sz="1800">
+                <a:solidFill>
+                  <a:srgbClr val="0F172A"/>
+                </a:solidFill>
+                <a:latin typeface="Calibri"/>
+              </a:rPr>
+              <a:t>• calcularPedidos sigue con la firma original: la normalización ocurre antes del scan.</a:t>
+            </a:r>
+          </a:p>
+          <a:p>
+            <a:pPr>
+              <a:spcAft>
+                <a:spcPts val="800"/>
+              </a:spcAft>
+            </a:pPr>
+            <a:r>
+              <a:rPr sz="1800">
+                <a:solidFill>
+                  <a:srgbClr val="0F172A"/>
+                </a:solidFill>
+                <a:latin typeface="Calibri"/>
+              </a:rPr>
+              <a:t>• Caso 0 — 20 clientes · 7 categorías · 182 records.</a:t>
+            </a:r>
+          </a:p>
+          <a:p>
+            <a:pPr>
+              <a:spcAft>
+                <a:spcPts val="800"/>
+              </a:spcAft>
+            </a:pPr>
+            <a:r>
+              <a:rPr sz="1800">
+                <a:solidFill>
+                  <a:srgbClr val="0F172A"/>
+                </a:solidFill>
+                <a:latin typeface="Calibri"/>
+              </a:rPr>
+              <a:t>• Caso 1 — 50 clientes · 20 categorías · 1 000 records.</a:t>
+            </a:r>
+          </a:p>
+          <a:p>
+            <a:pPr>
+              <a:spcAft>
+                <a:spcPts val="800"/>
+              </a:spcAft>
+            </a:pPr>
+            <a:r>
+              <a:rPr sz="1800">
+                <a:solidFill>
+                  <a:srgbClr val="0F172A"/>
+                </a:solidFill>
+                <a:latin typeface="Calibri"/>
+              </a:rPr>
+              <a:t>• Caso 2 — 100 clientes · 30 categorías · 5 000 records.</a:t>
+            </a:r>
+          </a:p>
+          <a:p>
+            <a:pPr>
+              <a:spcAft>
+                <a:spcPts val="800"/>
+              </a:spcAft>
+            </a:pPr>
+            <a:r>
+              <a:rPr sz="1800">
+                <a:solidFill>
+                  <a:srgbClr val="0F172A"/>
+                </a:solidFill>
+                <a:latin typeface="Calibri"/>
+              </a:rPr>
+              <a:t>• Tiempos medidos: 1 a 5 ms en ambas implementaciones (QuickSort y MergeSort).</a:t>
+            </a:r>
+          </a:p>
+        </p:txBody>
+      </p:sp>
+      <p:sp>
+        <p:nvSpPr>
+          <p:cNvPr id="5" name="TextBox 4"/>
+          <p:cNvSpPr txBox="1"/>
+          <p:nvPr/>
+        </p:nvSpPr>
+        <p:spPr>
+          <a:xfrm>
+            <a:off x="731520" y="6126480"/>
+            <a:ext cx="10515600" cy="365760"/>
+          </a:xfrm>
+          <a:prstGeom prst="rect">
+            <a:avLst/>
+          </a:prstGeom>
+          <a:noFill/>
+        </p:spPr>
+        <p:txBody>
+          <a:bodyPr wrap="none">
+            <a:spAutoFit/>
+          </a:bodyPr>
+          <a:lstStyle/>
+          <a:p>
+            <a:r>
+              <a:rPr sz="1600">
+                <a:solidFill>
+                  <a:srgbClr val="475569"/>
+                </a:solidFill>
+                <a:latin typeface="Calibri"/>
+              </a:rPr>
+              <a:t>Test 11 verifica que un caso con y sin prefijo de categorías produce el mismo ranking.</a:t>
+            </a:r>
           </a:p>
         </p:txBody>
       </p:sp>

</xml_diff>